<commit_message>
QA (Phase 8 Task 5): fix evidence grades + add PPT sources slide
- Align per-product evidence grade to products.csv market_evidence_grade
  (Replit B, Qoder B, Factory Unknown) — products.csv is the per-product
  dataset; candidates.csv current_evidence_grade is a distinct field (per
  08-sources.md §C1/C2), not a contradiction.
- Grade filter chips now built from actual grades present (incl. Unknown).
- Workflow stage 2 wording aligned to research note §10 (File/Component Editing).
- PPT: add 'Sources & Method' slide (traceability; 14 slides, within 10-15).
- Verification: 211/211 automated checks PASS; node --check on embedded JS
  exit 0; Phase 0-7 diff empty.
- No research judgment altered; no recomputation; no new ranking.
</commit_message>
<xml_diff>
--- a/cases/001-ai-coding-agent-landscape/08-presentation/executive-summary.pptx
+++ b/cases/001-ai-coding-agent-landscape/08-presentation/executive-summary.pptx
@@ -18,6 +18,7 @@
     <p:sldId id="266" r:id="rId17"/>
     <p:sldId id="267" r:id="rId18"/>
     <p:sldId id="268" r:id="rId19"/>
+    <p:sldId id="269" r:id="rId20"/>
   </p:sldIdLst>
   <p:sldSz cx="12191695" cy="6858000" type="screen4x3"/>
   <p:notesSz cx="6858000" cy="9144000"/>
@@ -3578,7 +3579,7 @@
                 </a:solidFill>
                 <a:latin typeface="Calibri"/>
               </a:rPr>
-              <a:t>Code Completion  →  Code / File Editing  →  Issue / Task Resolution  →  Repository-level Execution  →  Project / Product Work  →  Delegated Agent Workstream  →  Parallel Agent Portfolio  →  Engineering Workflow Automation</a:t>
+              <a:t>Code Completion  →  File/Component Editing  →  Issue / Task Resolution  →  Repository-level Execution  →  Project / Product Work  →  Delegated Agent Workstream  →  Parallel Agent Portfolio  →  Engineering Workflow Automation</a:t>
             </a:r>
           </a:p>
         </p:txBody>
@@ -5532,6 +5533,425 @@
 </file>
 
 <file path=ppt/slides/slide13.xml><?xml version="1.0" encoding="utf-8"?>
+<p:sld xmlns:a="http://schemas.openxmlformats.org/drawingml/2006/main" xmlns:p="http://schemas.openxmlformats.org/presentationml/2006/main" xmlns:r="http://schemas.openxmlformats.org/officeDocument/2006/relationships">
+  <p:cSld>
+    <p:spTree>
+      <p:nvGrpSpPr>
+        <p:cNvPr id="1" name=""/>
+        <p:cNvGrpSpPr/>
+        <p:nvPr/>
+      </p:nvGrpSpPr>
+      <p:grpSpPr/>
+      <p:sp>
+        <p:nvSpPr>
+          <p:cNvPr id="2" name="Rectangle 1"/>
+          <p:cNvSpPr/>
+          <p:nvPr/>
+        </p:nvSpPr>
+        <p:spPr>
+          <a:xfrm>
+            <a:off x="0" y="0"/>
+            <a:ext cx="12191695" cy="1051560"/>
+          </a:xfrm>
+          <a:prstGeom prst="rect">
+            <a:avLst/>
+          </a:prstGeom>
+          <a:solidFill>
+            <a:srgbClr val="12182A"/>
+          </a:solidFill>
+          <a:ln>
+            <a:noFill/>
+          </a:ln>
+          <a:effectLst/>
+        </p:spPr>
+        <p:style>
+          <a:lnRef idx="1">
+            <a:schemeClr val="accent1"/>
+          </a:lnRef>
+          <a:fillRef idx="3">
+            <a:schemeClr val="accent1"/>
+          </a:fillRef>
+          <a:effectRef idx="2">
+            <a:schemeClr val="accent1"/>
+          </a:effectRef>
+          <a:fontRef idx="minor">
+            <a:schemeClr val="lt1"/>
+          </a:fontRef>
+        </p:style>
+        <p:txBody>
+          <a:bodyPr rtlCol="0" anchor="ctr"/>
+          <a:lstStyle/>
+          <a:p>
+            <a:pPr algn="ctr"/>
+          </a:p>
+        </p:txBody>
+      </p:sp>
+      <p:sp>
+        <p:nvSpPr>
+          <p:cNvPr id="3" name="Rectangle 2"/>
+          <p:cNvSpPr/>
+          <p:nvPr/>
+        </p:nvSpPr>
+        <p:spPr>
+          <a:xfrm>
+            <a:off x="0" y="1051560"/>
+            <a:ext cx="12191695" cy="38100"/>
+          </a:xfrm>
+          <a:prstGeom prst="rect">
+            <a:avLst/>
+          </a:prstGeom>
+          <a:solidFill>
+            <a:srgbClr val="2F6FE0"/>
+          </a:solidFill>
+          <a:ln>
+            <a:noFill/>
+          </a:ln>
+          <a:effectLst/>
+        </p:spPr>
+        <p:style>
+          <a:lnRef idx="1">
+            <a:schemeClr val="accent1"/>
+          </a:lnRef>
+          <a:fillRef idx="3">
+            <a:schemeClr val="accent1"/>
+          </a:fillRef>
+          <a:effectRef idx="2">
+            <a:schemeClr val="accent1"/>
+          </a:effectRef>
+          <a:fontRef idx="minor">
+            <a:schemeClr val="lt1"/>
+          </a:fontRef>
+        </p:style>
+        <p:txBody>
+          <a:bodyPr rtlCol="0" anchor="ctr"/>
+          <a:lstStyle/>
+          <a:p>
+            <a:pPr algn="ctr"/>
+          </a:p>
+        </p:txBody>
+      </p:sp>
+      <p:sp>
+        <p:nvSpPr>
+          <p:cNvPr id="4" name="TextBox 3"/>
+          <p:cNvSpPr txBox="1"/>
+          <p:nvPr/>
+        </p:nvSpPr>
+        <p:spPr>
+          <a:xfrm>
+            <a:off x="502920" y="164592"/>
+            <a:ext cx="11185855" cy="731520"/>
+          </a:xfrm>
+          <a:prstGeom prst="rect">
+            <a:avLst/>
+          </a:prstGeom>
+          <a:noFill/>
+        </p:spPr>
+        <p:txBody>
+          <a:bodyPr wrap="square" anchor="ctr" lIns="50800" rIns="50800" tIns="25400" bIns="25400">
+            <a:spAutoFit/>
+          </a:bodyPr>
+          <a:lstStyle/>
+          <a:p>
+            <a:pPr algn="l"/>
+            <a:r>
+              <a:rPr sz="2800" b="1" i="0">
+                <a:solidFill>
+                  <a:srgbClr val="F2F5FA"/>
+                </a:solidFill>
+                <a:latin typeface="Calibri"/>
+              </a:rPr>
+              <a:t>Sources &amp; Method</a:t>
+            </a:r>
+          </a:p>
+        </p:txBody>
+      </p:sp>
+      <p:sp>
+        <p:nvSpPr>
+          <p:cNvPr id="5" name="TextBox 4"/>
+          <p:cNvSpPr txBox="1"/>
+          <p:nvPr/>
+        </p:nvSpPr>
+        <p:spPr>
+          <a:xfrm>
+            <a:off x="521207" y="713232"/>
+            <a:ext cx="11185855" cy="274320"/>
+          </a:xfrm>
+          <a:prstGeom prst="rect">
+            <a:avLst/>
+          </a:prstGeom>
+          <a:noFill/>
+        </p:spPr>
+        <p:txBody>
+          <a:bodyPr wrap="square" anchor="t" lIns="50800" rIns="50800" tIns="25400" bIns="25400">
+            <a:spAutoFit/>
+          </a:bodyPr>
+          <a:lstStyle/>
+          <a:p>
+            <a:pPr algn="l"/>
+            <a:r>
+              <a:rPr sz="1200" b="0" i="0">
+                <a:solidFill>
+                  <a:srgbClr val="9FB4D6"/>
+                </a:solidFill>
+                <a:latin typeface="Calibri"/>
+              </a:rPr>
+              <a:t>Traceability — every claim maps to 08-sources.md</a:t>
+            </a:r>
+          </a:p>
+        </p:txBody>
+      </p:sp>
+      <p:sp>
+        <p:nvSpPr>
+          <p:cNvPr id="6" name="TextBox 5"/>
+          <p:cNvSpPr txBox="1"/>
+          <p:nvPr/>
+        </p:nvSpPr>
+        <p:spPr>
+          <a:xfrm>
+            <a:off x="548640" y="1371600"/>
+            <a:ext cx="11094415" cy="4754880"/>
+          </a:xfrm>
+          <a:prstGeom prst="rect">
+            <a:avLst/>
+          </a:prstGeom>
+          <a:noFill/>
+        </p:spPr>
+        <p:txBody>
+          <a:bodyPr wrap="square">
+            <a:spAutoFit/>
+          </a:bodyPr>
+          <a:lstStyle/>
+          <a:p>
+            <a:pPr algn="l">
+              <a:spcAft>
+                <a:spcPts val="600"/>
+              </a:spcAft>
+            </a:pPr>
+            <a:r>
+              <a:rPr sz="1500" b="1">
+                <a:solidFill>
+                  <a:srgbClr val="2F6FE0"/>
+                </a:solidFill>
+                <a:latin typeface="Calibri"/>
+              </a:rPr>
+              <a:t>Source ledger  </a:t>
+            </a:r>
+            <a:r>
+              <a:rPr sz="1500">
+                <a:solidFill>
+                  <a:srgbClr val="12182A"/>
+                </a:solidFill>
+                <a:latin typeface="Calibri"/>
+              </a:rPr>
+              <a:t>08-sources.md registers 36 claims (C001–C036) and 131 sources (S001–S123 external + S200–S208 internal).</a:t>
+            </a:r>
+          </a:p>
+          <a:p>
+            <a:pPr algn="l">
+              <a:spcAft>
+                <a:spcPts val="600"/>
+              </a:spcAft>
+            </a:pPr>
+            <a:r>
+              <a:rPr sz="1500" b="1">
+                <a:solidFill>
+                  <a:srgbClr val="2F6FE0"/>
+                </a:solidFill>
+                <a:latin typeface="Calibri"/>
+              </a:rPr>
+              <a:t>Traceability chain  </a:t>
+            </a:r>
+            <a:r>
+              <a:rPr sz="1500">
+                <a:solidFill>
+                  <a:srgbClr val="12182A"/>
+                </a:solidFill>
+                <a:latin typeface="Calibri"/>
+              </a:rPr>
+              <a:t>Claim → Evidence → Source → Date → Evidence Grade → Confidence → Phase — unchanged from Phase 8 Task 2.</a:t>
+            </a:r>
+          </a:p>
+          <a:p>
+            <a:pPr algn="l">
+              <a:spcAft>
+                <a:spcPts val="600"/>
+              </a:spcAft>
+            </a:pPr>
+            <a:r>
+              <a:rPr sz="1500" b="1">
+                <a:solidFill>
+                  <a:srgbClr val="2F6FE0"/>
+                </a:solidFill>
+                <a:latin typeface="Calibri"/>
+              </a:rPr>
+              <a:t>Vendor claims  </a:t>
+            </a:r>
+            <a:r>
+              <a:rPr sz="1500">
+                <a:solidFill>
+                  <a:srgbClr val="12182A"/>
+                </a:solidFill>
+                <a:latin typeface="Calibri"/>
+              </a:rPr>
+              <a:t>Codex &gt;5M WAU, Copilot 4.7M/77K, Devin 1M+/4K, Qoder 6M+/100K, Replit 50M platform, Factory scale — retained as vendor claims, never market shares.</a:t>
+            </a:r>
+          </a:p>
+          <a:p>
+            <a:pPr algn="l">
+              <a:spcAft>
+                <a:spcPts val="600"/>
+              </a:spcAft>
+            </a:pPr>
+            <a:r>
+              <a:rPr sz="1500" b="1">
+                <a:solidFill>
+                  <a:srgbClr val="2F6FE0"/>
+                </a:solidFill>
+                <a:latin typeface="Calibri"/>
+              </a:rPr>
+              <a:t>Surveys ≠ shares  </a:t>
+            </a:r>
+            <a:r>
+              <a:rPr sz="1500">
+                <a:solidFill>
+                  <a:srgbClr val="12182A"/>
+                </a:solidFill>
+                <a:latin typeface="Calibri"/>
+              </a:rPr>
+              <a:t>JetBrains figures are multi-select (sum to 110%) and are never rendered as a single denominator.</a:t>
+            </a:r>
+          </a:p>
+          <a:p>
+            <a:pPr algn="l">
+              <a:spcAft>
+                <a:spcPts val="600"/>
+              </a:spcAft>
+            </a:pPr>
+            <a:r>
+              <a:rPr sz="1500" b="1">
+                <a:solidFill>
+                  <a:srgbClr val="2F6FE0"/>
+                </a:solidFill>
+                <a:latin typeface="Calibri"/>
+              </a:rPr>
+              <a:t>Benchmarks ≠ productivity  </a:t>
+            </a:r>
+            <a:r>
+              <a:rPr sz="1500">
+                <a:solidFill>
+                  <a:srgbClr val="12182A"/>
+                </a:solidFill>
+                <a:latin typeface="Calibri"/>
+              </a:rPr>
+              <a:t>Automated grader pass overstates maintainer acceptance by ~24.2 pts; no clean productivity estimate exists (C013, C014).</a:t>
+            </a:r>
+          </a:p>
+          <a:p>
+            <a:pPr algn="l">
+              <a:spcAft>
+                <a:spcPts val="600"/>
+              </a:spcAft>
+            </a:pPr>
+            <a:r>
+              <a:rPr sz="1500" b="1">
+                <a:solidFill>
+                  <a:srgbClr val="2F6FE0"/>
+                </a:solidFill>
+                <a:latin typeface="Calibri"/>
+              </a:rPr>
+              <a:t>Rendering only  </a:t>
+            </a:r>
+            <a:r>
+              <a:rPr sz="1500">
+                <a:solidFill>
+                  <a:srgbClr val="12182A"/>
+                </a:solidFill>
+                <a:latin typeface="Calibri"/>
+              </a:rPr>
+              <a:t>This deck introduces no new research, score, share, ranking or strategic claim. Phase 0–7 unmodified.</a:t>
+            </a:r>
+          </a:p>
+        </p:txBody>
+      </p:sp>
+      <p:sp>
+        <p:nvSpPr>
+          <p:cNvPr id="7" name="TextBox 6"/>
+          <p:cNvSpPr txBox="1"/>
+          <p:nvPr/>
+        </p:nvSpPr>
+        <p:spPr>
+          <a:xfrm>
+            <a:off x="365760" y="6473952"/>
+            <a:ext cx="8229600" cy="274320"/>
+          </a:xfrm>
+          <a:prstGeom prst="rect">
+            <a:avLst/>
+          </a:prstGeom>
+          <a:noFill/>
+        </p:spPr>
+        <p:txBody>
+          <a:bodyPr wrap="square" anchor="t" lIns="50800" rIns="50800" tIns="25400" bIns="25400">
+            <a:spAutoFit/>
+          </a:bodyPr>
+          <a:lstStyle/>
+          <a:p>
+            <a:pPr algn="l"/>
+            <a:r>
+              <a:rPr sz="900" b="0" i="0">
+                <a:solidFill>
+                  <a:srgbClr val="5C6B80"/>
+                </a:solidFill>
+                <a:latin typeface="Calibri"/>
+              </a:rPr>
+              <a:t>2026 AI Coding Agent Landscape — Executive Summary · Phase 8 Task 4 · rendering only, no new research</a:t>
+            </a:r>
+          </a:p>
+        </p:txBody>
+      </p:sp>
+      <p:sp>
+        <p:nvSpPr>
+          <p:cNvPr id="8" name="TextBox 7"/>
+          <p:cNvSpPr txBox="1"/>
+          <p:nvPr/>
+        </p:nvSpPr>
+        <p:spPr>
+          <a:xfrm>
+            <a:off x="11094415" y="6473952"/>
+            <a:ext cx="731520" cy="274320"/>
+          </a:xfrm>
+          <a:prstGeom prst="rect">
+            <a:avLst/>
+          </a:prstGeom>
+          <a:noFill/>
+        </p:spPr>
+        <p:txBody>
+          <a:bodyPr wrap="square" anchor="t" lIns="50800" rIns="50800" tIns="25400" bIns="25400">
+            <a:spAutoFit/>
+          </a:bodyPr>
+          <a:lstStyle/>
+          <a:p>
+            <a:pPr algn="r"/>
+            <a:r>
+              <a:rPr sz="1000" b="0" i="0">
+                <a:solidFill>
+                  <a:srgbClr val="5C6B80"/>
+                </a:solidFill>
+                <a:latin typeface="Calibri"/>
+              </a:rPr>
+              <a:t>13</a:t>
+            </a:r>
+          </a:p>
+        </p:txBody>
+      </p:sp>
+    </p:spTree>
+  </p:cSld>
+  <p:clrMapOvr>
+    <a:masterClrMapping/>
+  </p:clrMapOvr>
+</p:sld>
+</file>
+
+<file path=ppt/slides/slide14.xml><?xml version="1.0" encoding="utf-8"?>
 <p:sld xmlns:a="http://schemas.openxmlformats.org/drawingml/2006/main" xmlns:p="http://schemas.openxmlformats.org/presentationml/2006/main" xmlns:r="http://schemas.openxmlformats.org/officeDocument/2006/relationships">
   <p:cSld>
     <p:spTree>

</xml_diff>